<commit_message>
Add Mongolian speaker script for the India–Mongolia cyber cooperation briefing
Slide-by-slide speech in Mongolian (≈25 min) with timing table, stage
directions and Q&A preparation, as Markdown, Word and PDF. The same script is
now injected into the deck's speaker notes (src/speech_mn.js) above the
English version; README updated.

Co-Authored-By: Claude Fable 5.1 <noreply@anthropic.com>
Claude-Session: https://claude.ai/code/session_016FCt2Ew15svcZK9BeBoAhu
</commit_message>
<xml_diff>
--- a/india-cyber-cooperation/india_mongolia_cyber_cooperation.pptx
+++ b/india-cyber-cooperation/india_mongolia_cyber_cooperation.pptx
@@ -132,13 +132,13 @@
   <p:extLst>
     <p:ext uri="{521415D9-36F7-43E2-AB2F-B90AF26B5E84}">
       <p14:sectionLst xmlns:p14="http://schemas.microsoft.com/office/powerpoint/2010/main">
-        <p14:section name="Opening" id="{09eccf54-f00e-1d8e-f5f9-5639483d8baf}">
+        <p14:section name="Opening" id="{55611361-cba0-0eab-c632-f18a327b62f5}">
           <p14:sldIdLst>
             <p14:sldId id="256"/>
             <p14:sldId id="257"/>
           </p14:sldIdLst>
         </p14:section>
-        <p14:section name="01 Partnership context" id="{5609a97c-da0e-8d97-c981-39c7594f0c53}">
+        <p14:section name="01 Partnership context" id="{45b8e625-5451-e973-3245-cb7805ebfbf6}">
           <p14:sldIdLst>
             <p14:sldId id="258"/>
             <p14:sldId id="259"/>
@@ -146,7 +146,7 @@
             <p14:sldId id="261"/>
           </p14:sldIdLst>
         </p14:section>
-        <p14:section name="02 Establishing the Centre" id="{76dd0ab1-4920-13d1-2653-f7996e8e6278}">
+        <p14:section name="02 Establishing the Centre" id="{29b6711d-02d1-fc53-6610-2aef8174fdad}">
           <p14:sldIdLst>
             <p14:sldId id="262"/>
             <p14:sldId id="263"/>
@@ -156,7 +156,7 @@
             <p14:sldId id="267"/>
           </p14:sldIdLst>
         </p14:section>
-        <p14:section name="03 Results 2022–2026" id="{f922d3cb-c16a-41a9-4545-f2fc653c280b}">
+        <p14:section name="03 Results 2022–2026" id="{db5190b9-9059-16bc-e974-6b2e3130737c}">
           <p14:sldIdLst>
             <p14:sldId id="268"/>
             <p14:sldId id="269"/>
@@ -169,7 +169,7 @@
             <p14:sldId id="276"/>
           </p14:sldIdLst>
         </p14:section>
-        <p14:section name="04 The road ahead" id="{f062cd2b-dd78-c7d9-2a82-35b70a306b67}">
+        <p14:section name="04 The road ahead" id="{9dd9cb33-6a97-4ae0-720c-0e0f8c634efd}">
           <p14:sldIdLst>
             <p14:sldId id="277"/>
             <p14:sldId id="278"/>
@@ -177,7 +177,7 @@
             <p14:sldId id="280"/>
           </p14:sldIdLst>
         </p14:section>
-        <p14:section name="Closing" id="{c692e73c-485a-332f-2a3a-6ed09cab85d8}">
+        <p14:section name="Closing" id="{6f27f547-e9db-e54b-e373-10adf3784a16}">
           <p14:sldIdLst>
             <p14:sldId id="281"/>
           </p14:sldIdLst>
@@ -871,7 +871,11 @@
           <a:p>
             <a:r>
               <a:rPr lang="en-US" dirty="0"/>
-              <a:t>МН: Нээлтийн үг. Төлөөлөгчдийг угтаж, илтгэлийн зорилгыг нэг өгүүлбэрээр хэлнэ.
+              <a:t>Слайд 1 · Нүүр — 0.5 мин
+Эрхэм хүндэт Хамтарсан нарийн бичгийн дарга хатагтай Ишита Гангули Трипати, Захирал ноён Викаш Кумар, Захирал хурандаа Балжит Сингх, Батлан хамгаалахын атташе хурандаа Муппарти Санжеев, эрхэм хүндэт зочид оо!
+Өдрийн мэнд. Үндэсний батлан хамгаалахын их сургуулийн нэрийн өмнөөс та бүхнийг Кибер аюулгүй байдлын тэнхимд тавтай морилохыг урьж байна. Энэ тэнхим Энэтхэг улстай хамтран ажилласны бодит үр дүн юм. Тиймээс хоёр улсын Батлан хамгаалахын яамд хоорондын 14 дэх удаагийн зөвлөлдөх уулзалтын үеэр Энэтхэгийн Батлан хамгаалахын яамны төлөөлөгчдийг яг энэ байранд хүлээн авч байгаадаа бид онцгой баяртай байна.
+Дараагийн хорь гаруй минутад би дөрвөн зүйлийг танилцуулна: энэ хамтын ажиллагаа хаанаас эхэлсэн, Энэтхэгийн дэмжлэгээр энд юу бүтээгдсэн, 2022 оноос хойш ямар үр дүнд хүрсэн, цаашид бид юу санал болгож байна.
+— EN —
 Good morning. On behalf of the National Defence University of Mongolia, welcome to the Cyber Security Department. This Department exists because of our partnership with India, so it is a particular pleasure to host the Ministry of Defence delegation during the 14th Joint Working Group. In the next twenty-three minutes I will show where the cooperation came from, what has been built here with India's support, what it has delivered since 2022, and what we propose for the next phase.</a:t>
             </a:r>
             <a:endParaRPr lang="en-US" dirty="0"/>
@@ -960,7 +964,9 @@
           <a:p>
             <a:r>
               <a:rPr lang="en-US" dirty="0"/>
-              <a:t>МН: Сургалтын орчин: Тоон ул мөрийн лаборатори (12), Хортой код шинжлэх (14), Халдлага илрүүлэх ба аудит (11), 34 суудалтай лекцийн танхим, номын сан, багшийн өрөө (8), 2 рактай серверийн өрөө, даргын өрөө.
+              <a:t>Слайд 10 · Сургалтын орчин — 1 мин
+Илтгэлийн дараа та бүхэн энэ бүгдийг нүдээр үзнэ. [Зураг бүрийг богино заана.] Гурван лаборатори, нийт 37 ажлын станц: Тоон ул мөрийн шинжилгээний лаборатори 12 компьютертэй, Хортой кодын шинжилгээний лаборатори 14, Халдлага илрүүлэх ба аудитын лаборатори 11 компьютертэй, тус бүр ухаалаг самбар, принтертэй. 34 суудалтай лекцийн танхим; номын сан; найман багшийн ажлын өрөө; сервер, өгөгдөл хадгалах систем, галт хана, цахим сургалтын платформыг байрлуулсан хоёр рактай дата төв; тэнхимийн даргын өрөө.
+— EN —
 This is what the delegation will see on the tour: three laboratories with 37 workstations in total – digital forensics with twelve, malware analysis with fourteen, incident response and audit with eleven – each with smart boards and printers; a 34-seat lecture hall; a library; a staff room for eight instructors; a data centre with two racks hosting the servers, storage, firewall and the e-learning platform; and the head's office.</a:t>
             </a:r>
             <a:endParaRPr lang="en-US" dirty="0"/>
@@ -1049,7 +1055,10 @@
           <a:p>
             <a:r>
               <a:rPr lang="en-US" dirty="0"/>
-              <a:t>МН: 2023 оны 1 сард 5 орон тоотой төв → 2025 оны 7 сард ЦНС-ийн Кибер аюулгүй байдлын тэнхим: 7 багш, 3 бакалаврын хөтөлбөр, 162 кредит, анхны төгсөлт 2026.05.27.
+              <a:t>Слайд 11 · Сургалтын төвөөс их сургуулийн тэнхим болсон нь — 1 мин
+Төв 2023 оны 1 дүгээр сард таван орон тоотой эхэлсэн: төвийн дарга — миний бие, гурван багш. 2025 оны 7 дугаар сард Цэргийн нэгдсэн сургуулийн Кибер аюулгүй байдлын тэнхим болон өргөжиж, одоо ҮБХИС-ийн Кибер аюулгүй байдал, Сүлжээний инженер, Программ хангамжийн гурван бакалаврын хөтөлбөрийг хэрэгжүүлж байна.
+[Зүүн талын жагсаалт руу заана.] Багшлах бүрэлдэхүүн долоон хүн болтлоо өссөн. Ахлах багш дэслэгч Ч.Энхбаатар Энэтхэгт кибер аюулгүй байдлын мэргэжлийн сургалтад хамрагдсан. Энэ жил нэг багш докторын, хоёр багш магистрын зэрэг хамгаалсан. [Баруун доод тоонууд.] 2026 оны эхний хагаст тэнхим бакалаврын 162 кредитийн сургалт явуулж, 13 мэргэших хичээлийн хөтөлбөрийг улсын стандартад нийцүүлэн шинэчилсэн. 5 дугаар сарын 27-нд Кибер аюулгүй байдлын мэргэжлийн анхны энгийн ангийн төгсөлтийн улсын шалгалтыг амжилттай зохион байгуулсан.
+— EN —
 The Centre began in January 2023 with five posts: Captain Bilegt as head and three teachers. In July 2025 it was restructured into the Cyber Security Department of the Military Institute, which now runs NDU's bachelor programmes in cyber security, network engineering and software engineering. The faculty has grown to seven; two defended master's degrees and one a doctorate this year, and Lieutenant Enkhbaatar trained in India. In 2026 the Department delivered 162 credits of bachelor teaching, rewrote thirteen course units to the national standard, and graduated its first civilian cyber security cohort in May.</a:t>
             </a:r>
             <a:endParaRPr lang="en-US" dirty="0"/>
@@ -1138,7 +1147,11 @@
           <a:p>
             <a:r>
               <a:rPr lang="en-US" dirty="0"/>
-              <a:t>МН: Энэтхэгийн инженерүүд (C-DAC, 13 сар) болон 9 сургалтын баг (2023.09–2026.07), баг тус бүр 2 багш, 4 сар. 8, 9-р багийн нэрсийг тэнхимийн бүртгэлээс нөхнө.
+              <a:t>Слайд 12 · Энэтхэгийн инженер, сургалтын багууд — 1.5 мин
+Энэтхэгийн мэргэжилтнүүд 2022 оны 3 дугаар сараас хойш энд тасралтгүй ажиллаж байна. [Хүснэгтээр дээрээс доош.] Си-Ди-Эй-Си-ийн инженер Сандип Кумар, суурин инженер Викаш Шарма, Таранжит Сингх нар 13 сарын турш угсралт, ашиглалтыг хариуцаж, 2022 оны 9 дүгээр сард манай багш нарыг сургаж, 2023 оны 4 дүгээр сард лабораторийн хэрэгслийн сургалтыг явуулсан.
+2023 оны 8 дугаар сараас Энэтхэгийн Агаарын хүчин, Тэнгисийн цэргийн хүчин, Хуурай замын цэргийн хоёр хоёр багш бүхий есөн сургалтын баг дөрвөн сар тутам ээлжлэн ирж, хоёр талын баталсан 2024–2026 оны сургалтын төлөвлөгөөний дагуу баг бүр нэг, хоёр мэргэшүүлэх курс заасан. Эхний баг — доктор М.К.Шарма, Винод Кумар Шарма нар — багш бэлтгэх хөтөлбөр, сүлжээний аюулгүй байдал, хортой кодын шинжилгээг; дараагийн багууд кибер аюулгүй байдлын үндсэн курс, ёс зүйт халдлага, SOC шинжээч, тоон ул мөр, сүлжээний администратор, криптограф, нэвтрэлтийн тест, аудит, суурь курсийг заасан. Долоо дахь баг — дэслэгч хурандаатай дүйх Wing Commander Кишор Ядав тэргүүтэй — арван долоо хоногийн суурь сургалтыг явуулсан. Найм, ес дэх баг 2026 онд хамгаалалтын буюу Blue Team болон ахисан түвшний блокийг хэрэгжүүлсэн.
+Энэ ээлжлэх тогтолцоо манай хөтөлбөрийг Энэтхэгийн зэвсэгт хүчний практиктай уялдуулаад зогсохгүй хоёр улсын цэргийн хооронд хувь хүний холбоо, итгэлцлийг бий болгосон.
+— EN —
 Indian expertise has been on site continuously since March 2022. C-DAC's engineers stayed for thirteen months, trained our teachers in September 2022 and ran the laboratory tools course in April 2023. Since August 2023 nine mobile training teams of two instructors, drawn from the Indian Air Force, Navy and Army, have rotated every four months under the plan the two sides approved for 2024–2026, each delivering one or two specialised courses. [Walk through the table.] Beyond the classroom, the rotation keeps our curriculum aligned with Indian service practice and has built personal links between the two services.</a:t>
             </a:r>
             <a:endParaRPr lang="en-US" dirty="0"/>
@@ -1227,7 +1240,10 @@
           <a:p>
             <a:r>
               <a:rPr lang="en-US" dirty="0"/>
-              <a:t>МН: Хэсгийн хуудас.
+              <a:t>Слайд 13 · 03 — 2022–2026 оны үр дүн
+[Хэсгийн хуудас.]
+Гуравдугаар хэсэг: үр дүн.
+— EN —
 Part three: results.</a:t>
             </a:r>
             <a:endParaRPr lang="en-US" dirty="0"/>
@@ -1316,7 +1332,10 @@
           <a:p>
             <a:r>
               <a:rPr lang="en-US" dirty="0"/>
-              <a:t>МН: Сургалтын үр дүн: 2022.09–2025.06-д 13 ээлжид 211 хүн (график); 2022–2026 онд нийт 300 гаруй мэргэжилтэн (ҮБХИС-ийн 2026.10.09-ний албан бичиг); 2026 оны эхний хагаст 20 кредит.
+              <a:t>Слайд 14 · 300 гаруй мэргэжилтэн — 1.5 мин
+[График руу заана.] Энэ графикт 2022 оны 9 сарын багш нарын сургалтаас 2025 оны 6 сарын аудитын курс хүртэлх ээлж бүр харагдаж байна: 13 ээлж, 211 суралцагч. Хамгийн олон хүнтэй нь кибер аюулгүй байдлын үндсэн курс — 24, сүлжээний администратор — 22, нэвтрэлтийн тест — 21 хүн. Үүний дараа долоо, найм, ес дэх баг 2026 оны 7 дугаар сар хүртэл суурь, хамгаалалтын, ахисан түвшний циклийг явуулсан.
+Нийтдээ — ҮБХИС энэ сарын эхээр Батлан хамгаалах яаманд тайлагнаснаар — 2022–2026 онд Энэтхэгийн сургалтын багтай хамтран төрийн цэргийн болон хууль сахиулах байгууллагын 300 гаруй мэргэжилтнийг олон улсын жишигт нийцсэн сургалтад хамруулсан. Зөвхөн 2026 оны эхний хагаст тэнхим Энэтхэгийн багтай хамтран 20 кредитийн мэргэшүүлэх сургалт явуулсан.
+— EN —
 The chart shows every course cohort from the first teacher training in September 2022 to the audit course in June 2025: thirteen cohorts, 211 trainees, with the largest intakes in the basic course, network administration and penetration testing. The seventh, eighth and ninth teams then ran the foundation, blue-team and advanced cycles through July 2026. In total, as NDU reported to the Ministry this month, more than three hundred specialists of the military and law-enforcement agencies have been trained with the Indian teams, and in the first half of 2026 alone the Department delivered twenty credits of specialised training with them.</a:t>
             </a:r>
             <a:endParaRPr lang="en-US" dirty="0"/>
@@ -1405,7 +1424,9 @@
           <a:p>
             <a:r>
               <a:rPr lang="en-US" dirty="0"/>
-              <a:t>МН: 2024–2026 оны хамтарсан сургалтын төлөвлөгөө: 9 үе шат – багш бэлтгэх, үндсэн курс, CEH, хортой код/тоон ул мөр, сүлжээний админ/крипто, VAPT/аудит, суурь, хамгаалалт (Blue Team), ахисан түвшин.
+              <a:t>Слайд 15 · Хамтран баталсан хөтөлбөр: есөн үе шат — 1 мин
+Бид тохиолдлын курс биш, есөн үе шаттай нэгдсэн хөтөлбөрийг хоёр талаас тохиролцон хэрэгжүүлсэн. 2023 онд багш бэлтгэх сургалтаас эхлээд үндсэн курс, ёс зүйт халдлага, хортой код ба тоон ул мөр, сүлжээний администратор ба криптограф, нэвтрэлтийн тест ба аудит гэж ахиж, 2025–2026 оны мэргэжлийн циклээр үргэлжилсэн: арван долоо хоногийн суурь, хамгаалалтын Blue Team блок, эцэст нь CERT-ийн үйл ажиллагаа, цэргийн кибер ажиллагаагаар төгсдөг ахисан түвшний блок. Үе шат бүр нэг сургалтын багт ногдоно. Бүх курсийн хөтөлбөрийг англи, монгол хэлээр боловсруулсан тул тэнхим Энэтхэгийн баггүйгээр ч эдгээр сургалтыг давтан явуулах чадвартай болсон.
+— EN —
 Rather than ad-hoc courses, the two sides agreed a nine-phase curriculum running from instructor training in 2023 through basic, ethical hacking, malware and forensics, network administration and cryptography, penetration testing and audit, to the 2025–26 professional cycle: a ten-week foundation, a defensive blue-team block and an advanced block ending with CERT operations and military cyber security operations. Each phase matches one training team. All course programmes were written in English and Mongolian, so the Department can repeat them without the Indian team.</a:t>
             </a:r>
             <a:endParaRPr lang="en-US" dirty="0"/>
@@ -1494,7 +1515,10 @@
           <a:p>
             <a:r>
               <a:rPr lang="en-US" dirty="0"/>
-              <a:t>МН: Сургалтад хамрагдагчид: Кибер аюулгүй байдлын цэргийн командлал, ЗХ-ний нэгтгэл, анги (016, 011), ҮБХИС-ийн багш, сонсогч, ТЕГ, ТТХГ, НОБГ, ҮАБЗ-ийн хөтөлбөр; 8 гэрээ, 22 сурагч, 3 бакалаврын хөтөлбөр, анхны төгсөлт.
+              <a:t>Слайд 16 · Хэнийг сургадаг вэ — 1 мин
+Төв зөвхөн Зэвсэгт хүчинд биш, салбарт бүхэлд нь үйлчилдэг. Кибер аюулгүй байдлын цэргийн командлал 2023 оны 4 дүгээр сард анхны ээлжийг илгээсэн, одоо ч гол түнш хэвээр. Зэвсэгт хүчний нэгтгэл, анги, Жанжин штаб мэдлэг олгох сургалтад хамрагддаг. ҮБХИС-ийн багш, сонсогчдыг хамгийн түрүүнд сургасан нь сургалтыг давтан явуулах боломж бүрдүүлсэн. Тагнуулын ерөнхий газар, Төрийн тусгай хамгаалалтын газар, Нийслэлийн онцгой байдлын газар сургалтын гэрээгээр мэргэжилтнээ илгээдэг. 2025 онд тэнхим Үндэсний аюулгүй байдлын зөвлөлийн кибер чадавх бэхжүүлэх хөтөлбөрийн гүйцэтгэгчээр шалгарсан.
+[Баруун талын тоонууд.] Байгууллага, хувь хүнтэй найман сургалтын гэрээ байгуулсан, 2025 оны мэргэжил сурталчлах хөтөлбөрөөр 22 сурагчид батламж олгосон, гурван бакалаврын хөтөлбөр хэрэгжүүлж, анхны энгийн ангиа энэ 5 дугаар сард төгсгөсөн.
+— EN —
 The Centre serves the whole sector, not only the Armed Forces. The Cyber Security Military Command sent the very first cohort in April 2023 and remains our principal partner. Units and the General Staff receive awareness training; NDU's own faculty and cadets were trained first so that the courses could be repeated; the General Intelligence Agency, the State Special Protection Agency and the Capital Emergency Department send specialists under training contracts; and in 2025 the Department was selected to execute the National Security Council's cyber capacity programme. The Department also runs three bachelor programmes and graduated its first civilian cohort in May.</a:t>
             </a:r>
             <a:endParaRPr lang="en-US" dirty="0"/>
@@ -1583,7 +1607,9 @@
           <a:p>
             <a:r>
               <a:rPr lang="en-US" dirty="0"/>
-              <a:t>МН: Судалгаа, инновац: ISBN бүхий 8 сурах бичиг (2025), БЭХИ сургалтын систем (ҮБХИС-ийн шилдэг инновац 2025, БХ-ын сайдын шагналын дэд байр), 8 өгүүлэл, 2026.02 салбарын ЭШ хурал + DefendX, олимпиадын тэргүүн байр.
+              <a:t>Слайд 17 · Судалгаа, сурах бичиг, инновац — 1 мин
+Энэтхэгийн хөтөлбөр манай өөрийн судалгаа, сургалтын материалын үр болсон. [Зүүн талын номнуудыг заана.] 2025 онд багш нар сүлжээний аюулгүй байдлаас мэдээллийн системийн аудит хүртэл ISBN дугаартай найман англи хэлний сурах бичиг эмхэтгэн, тус бүр 20 хувийг ҮБХИС-ийн номын санд байршуулсан. Багш нар өөрсдөө "БЭХИ" сургалтын системийг хөгжүүлсэн нь ҮБХИС-ийн 2025 оны Эрдмийн их чуулганд шилдэг инновацын бүтээлээр шалгарч, Батлан хамгаалахын сайдын нэрэмжит шинжлэх ухаан, технологийн шилдэг бүтээлийн уралдаанд дэд байр эзэлсэн. Мөн найман эрдэм шинжилгээний өгүүлэл нийтлүүлсэн. 2026 оны 2 дугаар сард тэнхим таван их сургууль, академийг оролцуулсан салбарын эрдэм шинжилгээний хурлыг "DefendX-2026" ур чадварын тэмцээний хамт зохион байгуулсан бөгөөд манай сонсогч Улсын компьютерийн сүлжээний олимпиадад тэргүүн байр эзэлсэн.
+— EN —
 The Indian curriculum has become the seed of our own research and teaching material. In 2025 the faculty compiled eight English-language textbooks with ISBNs, from network security to information systems audit, now in the NDU library. They built the BEKHI learning system, which won the best-innovation award at the 2025 NDU Academic Conference and second place in the Defence Minister's science and technology award, and published eight articles. In February 2026 the Department hosted the sector conference with five universities and academies alongside the DefendX-2026 competition, and our cadet won the national computer network olympiad.</a:t>
             </a:r>
             <a:endParaRPr lang="en-US" dirty="0"/>
@@ -1672,7 +1698,10 @@
           <a:p>
             <a:r>
               <a:rPr lang="en-US" dirty="0"/>
-              <a:t>МН: Багшийн хөгжил: Энэтхэгт суралцсан, доктор 1, магистр 2, ХБНГУ/Япон/АНУ-ын сургалт, Pacific Endeavor, ITACTIC. Түншүүд: КАБЦК, ҮАБЗ, MNCERT, их сургуулиуд, хувийн хэвшил, дадлага.
+              <a:t>Слайд 18 · Багшийн хөгжил, түншлэлийн сүлжээ — 1 мин
+Энэтхэгийн хөрөнгө оруулалт манай хүмүүсийн өсөлтөөр үржиж байна. Дэслэгч Энхбаатар Энэтхэгт суралцсан; энэ жил багш нар нэг доктор, хоёр магистрын зэрэг хамгаалж, Герман, Япон, Америкийн Нэгдсэн Улсад сургалтад хамрагдсан; миний бие "Pacific Endeavor" сургууль, кибер халдлагад хариу үзүүлэх "ITACTIC" команд штабын сургуульд оролцсон.
+Төв мөн өргөн түншлэлийн сүлжээний тулгуур болж байна: Кибер аюулгүй байдлын цэргийн командлал, АНУ-ын Энэтхэг–Номхон далайн командлалын мэргэжилтнүүдтэй хамтарсан сургалт; Үндэсний аюулгүй байдлын зөвлөлийн чадавхын хөтөлбөр; үндэсний CERT, гурван их сургууль; манай сонсогчдыг дадлагад авдаг аж ахуйн нэгжүүд.
+— EN —
 The Indian investment is multiplied by the growth of our own people. Lieutenant Enkhbaatar trained in India; this year the faculty defended one doctorate and two master's degrees and attended courses in Germany, Japan and the United States; and the head took part in Pacific Endeavor and the ITACTIC incident-response exercise. The Centre also anchors a wider network: joint training with the Cyber Security Military Command and US Indo-Pacific Command specialists, the National Security Council's capacity programme, the national CERT, three universities, and industry partners who host our cadets for internships.</a:t>
             </a:r>
             <a:endParaRPr lang="en-US" dirty="0"/>
@@ -1761,7 +1790,9 @@
           <a:p>
             <a:r>
               <a:rPr lang="en-US" dirty="0"/>
-              <a:t>МН: 2025 оны шинэчлэл: 2025.06.10-ны нийлүүлэлтийн захиалга (DCyA/C-DAC), 37 компьютерийн RAM/видео карт/диск шинэчлэл (2025.11.06 суурилуулсан), 15 программын лиценз (2025.09.30–11.07), гааль 09.07, 10.13.
+              <a:t>Слайд 19 · Энэтхэгийн үргэлжилсэн дэмжлэг: 2025 оны шинэчлэл — 1 мин
+Энэтхэгийн дэмжлэг нээлтээр дууссангүй. Энэтхэгийн Батлан хамгаалахын кибер агентлагийн 2025 оны 6 дугаар сарын 10-ны нийлүүлэлтийн захиалгаар Си-Ди-Эй-Си бүх 37 ажлын станцад шинэ санах ой, видео карт, нэг терабайтын диск суурилуулж, 2025 оны 11 дүгээр сарын 6-нд ашиглалтад хүлээлгэн өгсөн. 9–11 дүгээр сард 15 мэргэжлийн программын лицензийг сунгаж, шинээр авсан: FTK, Cellebrite, Oxygen, Belkasoft зэрэг шинжилгээний багц, IDA Pro, Nessus, Burp Suite, Acunetix, Invicti, VMware болон Red Hat платформ, галт ханын захиалга. Тэнхим гаалийн бүрдүүлэлтийг Батлан хамгаалах яамтай хамтран зохион байгуулж, Си-Ди-Эй-Си-ийн инженертэй хамт суурилуулсан.
+— EN —
 India's support did not stop at the inauguration. Under a supply order of 10 June 2025 from the Defence Cyber Agency, executed by C-DAC, all 37 workstations received new memory, graphics cards and one-terabyte disks, commissioned on 6 November 2025, and fifteen professional licences were renewed or newly issued between September and November: the forensic suites FTK, Cellebrite, Oxygen and Belkasoft, IDA Pro, Nessus, Burp Suite, Acunetix and Invicti, the VMware and Red Hat platforms and the firewall subscription. The Department organised customs clearance with the Ministry and installed the items with the C-DAC engineer.</a:t>
             </a:r>
             <a:endParaRPr lang="en-US" dirty="0"/>
@@ -1850,7 +1881,11 @@
           <a:p>
             <a:r>
               <a:rPr lang="en-US" dirty="0"/>
-              <a:t>МН: Төлөөлөгчдийг нэрээр нь хүндэтгэн дурдаж, илтгэлийн 4 хэсэг, хугацааг танилцуулна.
+              <a:t>Слайд 2 · Угтах үг, товч агуулга — 1 мин
+Юуны өмнө зочдоо дахин нэрлэн хүндэтгэе. Хамтарсан нарийн бичгийн дарга хатагтай Ишита Гангули Трипати; Захирал ноён Викаш Кумар; Захирал хурандаа Балжит Сингх; Батлан хамгаалахын атташе хурандаа Муппарти Санжеев. Хурандаа Санжеев өнгөрсөн жил манай тэнхимд зочилж, Энэтхэгийн сургалтын багтай хамтран хэрэгжүүлж буй үйл ажиллагаатай танилцсан тул энэ байр түүнд танил.
+Илтгэл дөрвөн хэсэгтэй. Нэгдүгээрт, хамтын ажиллагааны суурь: долоон арван жилийн харилцаа, батлан хамгаалах салбарын хамтын ажиллагааны дөрвөн тулгуур. Хоёрдугаарт, төвийг хэрхэн байгуулсан: 2015 оны санамж бичгээс 2022 оны нээлт хүртэл, Энэтхэгийн хувь нэмэр, хүмүүс. Гуравдугаарт, 2022–2026 оны үр дүн: сургалт, хөтөлбөр, судалгаа, 2025 оны шинэчлэл. Дөрөвдүгээрт, цаашдын хамтын ажиллагаа: дараагийн үе шатны санал, 14 дэх зөвлөлдөх уулзалтад оруулах саналууд.
+Илтгэлийн дараа асуултад хариулж, дараа нь лабораториудаар хамт явна.
+— EN —
 Let me first acknowledge our guests: Ms Ishita Ganguli Tripathy, Joint Secretary; Mr Vikash Kumar and Colonel Baljit Singh, Directors; and Colonel Mupparty Sanjeev, Defence Attaché, who already knows this Department from his visit last year. The briefing has four parts: the partnership context, how the Centre was established, what it has delivered since 2022, and our proposals for the next phase. We will then take questions and walk through the laboratories.</a:t>
             </a:r>
             <a:endParaRPr lang="en-US" dirty="0"/>
@@ -1939,7 +1974,9 @@
           <a:p>
             <a:r>
               <a:rPr lang="en-US" dirty="0"/>
-              <a:t>МН: Он дарааллын гол үйл явдлууд: нээлт, орон тоо, JWG 11–13, эхний баг, 2024–26 төлөвлөгөө, Элчин сайдын айлчлал, тэнхим, Төрийн айлчлал, 2025 шинэчлэл ба Атташегийн айлчлал, төсөл дууссан 2026.07, багш 2029 хүртэл, JWG-14.
+              <a:t>Слайд 20 · 2022–2026 оны гол үйл явдлууд — 1 мин
+Нэг он дараалал дээр тавьж үзвэл хамтын ажиллагаа тогтвортой хэмнэлтэй: Энэтхэгийн талаас нэг алхам, манай талаас нэг алхам, жил бүр зөвлөлдөх уулзалтаар дүгнэдэг. 2024 онд Энэтхэгийн Элчин сайд төвд зочилж, шинэчлэлийн хэрэгцээтэй танилцсан нь 2025 оны шинэчлэлд хүргэсэн. 2025 оны 10 дугаар сарын Төрийн айлчлал, шинээр томилогдсон Батлан хамгаалахын атташе — өнгөрсөн 11 дүгээр сард манай тэнхимд зочилсон — хамтын ажиллагаанд Улаанбаатарт байнгын суваг бий болгосон. Төслийн хэрэгжилтийн хугацаа 2026 оны 7 дугаар сард албан ёсоор дууссан ч Засгийн газар хоорондын санамж бичгийн хүрээнд багш илгээх асуудлыг 2029 он хүртэл үргэлжлүүлэхээр болсон. Энэ нь биднийг саналын хэсэгт хүргэж байна.
+— EN —
 Put on one timeline, the cooperation shows a steady rhythm: an institutional step on the Indian side, a step on ours, and a Joint Working Group each year to review it. The Ambassador's visit in 2024 led to the 2025 upgrade; the President's visit in October 2025 and the new Defence Attaché, who visited the Department last November, have given the partnership a permanent channel in Ulaanbaatar. The project phase formally ended in July 2026, but under the intergovernmental Memorandum instructor deployment has already been extended to 2029 – which brings us to the proposals.</a:t>
             </a:r>
             <a:endParaRPr lang="en-US" dirty="0"/>
@@ -2028,7 +2065,10 @@
           <a:p>
             <a:r>
               <a:rPr lang="en-US" dirty="0"/>
-              <a:t>МН: Сургамж: хамтын загвар, суурин инженер, 3 жилийн төлөвлөгөө, хоёр хэлний хөтөлбөр, салбар даяар сонголт, 2025 шинэчлэл. Сорилт: багшийн хүрэлцээ (2023), гэрчилгээ, кибер полигон/онлайн платформ, төсөв, залгамж халаа, II шатны хүрээ.
+              <a:t>Слайд 21 · Сургамж, сорилт — 1.5 мин
+Сургамжууд бидний саналыг тодорхойлсон тул илэн далангүй хэлье. [Зүүн карт.] Юу үр дүнтэй байсан бэ: Энэтхэгийн технологи, хөтөлбөр, багш, Монголын байр, боловсон хүчин, удирдлага гэсэн хуваарилалттай хамтын загвар; эхний жил суурин инженерүүд ажилласан тул нээлтээс хэдхэн долоо хоногийн дараа сургалт эхэлсэн; дөрвөн сарын ээлжтэй гурван жилийн төлөвлөгөө; Батлан хамгаалахын сайд, ҮБХИС-ийн захирлын тушаалаар явагддаг хоёр хэлний хөтөлбөрүүд; салбар даяар элсүүлсэн суралцагчид; 2025 оны шинэчлэл.
+[Баруун карт.] Сорилтууд: 2023 оны дүгнэлтээр багш нарын ачаалал 100 хувь байхад анги танхимын ашиглалт 50 хувь байсан — илүү олон багш хэрэгтэй байсныг 2025 оны бүтцийн өөрчлөлт хэсэгчлэн шийдсэн; манай гэрчилгээ үндэсний хэмжээнд мэргэжлийн хүлээн зөвшөөрөлт аваагүй байна; нийслэлээс гадуурх нэгжүүдэд зориулсан кибер полигон, онлайн сургалтын платформ байхгүй — үүнийг 2024 оноос хойш хүсэлт болгож ирсэн; төсвийн хязгаарлалтаас болж нэг хурал, нэг лаборатори хойшилсон; ээлж бүрт залгамж халаа шаардлагатай; төслийн үе шат 2026 оны 7 сард хаагдсан тул багш илгээхээс цаашилсан хоёрдугаар үе шатны хүрээ хэрэгтэй.
+— EN —
 Let me be candid, because the lessons shape our proposals. What worked: the shared delivery model, resident engineers in the first year, a three-year plan with four-month rotations, bilingual course programmes, sector-wide recruitment, and India's 2025 renewal. The challenges: our 2023 review found the faculty fully loaded while classrooms were half used – more instructors were needed, which the 2025 restructuring partly addressed; our certificates still lack national professional recognition; we have no cyber range or online platform for units outside the capital, which we have asked for since 2024; budget limits postponed a conference and a laboratory; each rotation needs a handover; and with the project phase closed in July 2026 we need a Phase II framework.</a:t>
             </a:r>
             <a:endParaRPr lang="en-US" dirty="0"/>
@@ -2117,7 +2157,10 @@
           <a:p>
             <a:r>
               <a:rPr lang="en-US" dirty="0"/>
-              <a:t>МН: Хэсгийн хуудас.
+              <a:t>Слайд 22 · 04 — Цаашдын хамтын ажиллагаа
+[Хэсгийн хуудас.]
+Дөрөвдүгээр хэсэг: бидний санал.
+— EN —
 Part four: our proposals.</a:t>
             </a:r>
             <a:endParaRPr lang="en-US" dirty="0"/>
@@ -2206,7 +2249,14 @@
           <a:p>
             <a:r>
               <a:rPr lang="en-US" dirty="0"/>
-              <a:t>МН: ҮБХИС-ийн 2026.10.09-ний 01/1171 албан бичгийн 4 чиглэл: хамтарсан сургалт (бакалавр/магистр/доктор, солилцоо, хос диплом); лаборатори (Cyber Range, SOC, IoT/AI/их өгөгдөл/квант, НННХ); багшийн чадавх; олон улсын хамтын ажиллагаа (ITU Cyberdrill, FIRST, APCERT, 2 жил тутмын форум).
+              <a:t>Слайд 23 · ҮБХИС-ийн санал болгосон дөрвөн чиглэл — 1.5 мин
+2026 оны 10 дугаар сарын 9-нд ҮБХИС дараагийн үе шатны дөрвөн чиглэлийг Батлан хамгаалах яаманд хүргүүлсэн бөгөөд яам үүнийг энэ зөвлөлдөх уулзалтын ярианы сэдэвт оруулсанд талархаж байна.
+Нэг — хамтарсан сургалт: кибер аюулгүй байдлын чиглэлээр хамтарсан бакалавр, магистр, докторын хөтөлбөр; багш, сонсогч, судлаачийн солилцоо; Энэтхэгийн их сургуулиудтай хос диплом олгох хөтөлбөр.
+Хоёр — лаборатори, судалгаа: кибер полигон болон Аюулгүй байдлын ажиллагааны төвийн лаборатори; IoT, хиймэл оюун, их өгөгдөл, квант криптографын хамтарсан судалгааны төв; нисгэгчгүй болон алсын удирдлагатай системийн кибер аюулгүй байдлын лаборатори.
+Гурав — багшийн чадавх: манай багш, судлаачдыг Энэтхэгийн батлан хамгаалахын их сургууль, судалгааны байгууллагад сургах; кибер аюулгүй байдлын багш бэлтгэх хамтарсан хөтөлбөр.
+Дөрөв — олон улсын хамтын ажиллагаа: ITU Cyberdrill, FIRST, APCERT-ийн сургуулиудад хамтран оролцох; хоёр жил тутмын Монгол–Энэтхэгийн кибер аюулгүй байдлын форум; хамтарсан хурал, семинар, сургалт, дадлага сургууль тогтмол зохион байгуулах.
+[Доод өгүүлбэр.] Багш илгээх асуудал санамж бичгийн хүрээнд 2029 он хүртэл аль хэдийн сунгагдсан; эдгээр чиглэл тэр суурин дээр дараагийн давхаргыг барина.
+— EN —
 On 9 October NDU sent the Ministry of Defence four directions for the next phase, and we are grateful that the Ministry proposed them for this Joint Working Group. First, joint education: joint bachelor, master's and doctoral programmes, exchanges, and double degrees. Second, laboratories and research: a cyber range and SOC laboratory, a joint research centre on IoT, AI, big data and quantum cryptography, and a laboratory for the cyber security of unmanned and remotely operated systems. Third, faculty capacity: training our faculty at Indian defence universities and a joint programme for cyber security instructors. Fourth, international cooperation: joint participation in ITU Cyberdrill, FIRST and APCERT exercises, a biennial Mongolia–India Cyber Security Forum, and regular joint events.</a:t>
             </a:r>
             <a:endParaRPr lang="en-US" dirty="0"/>
@@ -2295,7 +2345,9 @@
           <a:p>
             <a:r>
               <a:rPr lang="en-US" dirty="0"/>
-              <a:t>МН: Замын зураг 2026–2030: багш нар 2029 хүртэл; Cyber Range/SOC 2027 үнэлгээ → 2028 ашиглалт; хамтарсан хөтөлбөр 2027 боловсруулах → 2028 элсэлт; багш нарын сургалт жил бүр; судалгааны төв 2028–; форум 2027, 2029; ITU/FIRST/APCERT жил бүр.
+              <a:t>Слайд 24 · 2026–2030 оны замын зураг — 1 мин
+Хугацааны хуваарь дээр тавьж үзвэл багц ингэж харагдана. Тохиролцсоны дагуу багшийн ээлж 2029 он хүртэл үргэлжилнэ. 2027 оны техникийн үнэлгээний үндсэн дээр кибер полигон, SOC лаборатори 2028 онд ашиглалтад орно. Хамтарсан болон хос дипломын хөтөлбөрийг 2027 онд боловсруулж магадлан итгэмжлүүлээд 2028 оноос анхны элсэлтийг авна. 2027 оноос жил бүр хоёр багш Энэтхэгт суралцана. Хамтарсан судалгааны төв 2028 оноос. Монгол–Энэтхэгийн кибер аюулгүй байдлын анхны форумыг 2027 онд, хоёр дахийг 2029 онд зохион байгуулж, 2027 оноос ITU, FIRST, APCERT-ийн сургуулиудад хамтран оролцоно. 2029 онд санамж бичгийн багш илгээх хугацааг дахин хэлэлцэнэ.
+— EN —
 Put on a timeline, the package looks like this. Instructor rotations continue to 2029 as already agreed. A technical assessment in 2027 leads to a cyber range and SOC laboratory operational in 2028. Joint and double-degree programmes are designed and accredited in 2027 so that the first intakes start in 2028. Two faculty members a year train in India from 2027. The joint research centre follows in 2028. The first Mongolia–India Cyber Security Forum is held in 2027 and the second in 2029, and from 2027 we take part together in the ITU, FIRST and APCERT exercises. In 2029 the Memorandum's instructor term comes up for review.</a:t>
             </a:r>
             <a:endParaRPr lang="en-US" dirty="0"/>
@@ -2384,7 +2436,15 @@
           <a:p>
             <a:r>
               <a:rPr lang="en-US" dirty="0"/>
-              <a:t>МН: 14 дэх зөвлөлдөх уулзалтад оруулах 5 санал: II шатыг протоколд тусгах; багш 2029 хүртэл + 2027–2029 төлөвлөгөө; Cyber Range/SOC лаборатори (2027 үнэлгээ); багшийн суудал, хамтарсан хөтөлбөр; 2027 форум, ITU/FIRST/APCERT.
+              <a:t>Слайд 25 · 14 дэх зөвлөлдөх уулзалтад оруулах санал — 1.5 мин
+Замын зургийг шийдвэр болгохын тулд бид 14 дэх зөвлөлдөх уулзалтад таван тодорхой санал оруулж байна. Энэтхэгийн талыг дараах асуудлыг авч үзэхийг хүсье.
+Нэг: Кибер аюулгүй байдлын сургалтын төвийн төслийг өргөжүүлэх — хоёрдугаар үе шат — асуудлыг уулзалтын хэлэлцэх асуудал, протоколд тусгах.
+Хоёр: багш илгээхийг 2029 он хүртэл баталгаажуулж, 2024–2026 оны төлөвлөгөөний жишгээр монгол багш бэлтгэх чиглэл бүхий 2027–2029 оны хамтарсан сургалтын төлөвлөгөөг батлах.
+Гурав: кибер полигон, SOC лаборатори бүхий хоёрдугаар үе шатны лабораторийн төслийг тохиролцож, 2027 онд Си-Ди-Эй-Си болон Батлан хамгаалахын кибер агентлагийн техникийн үнэлгээ хийлгэх.
+Дөрөв: 2027 оноос манай багш нарт Энэтхэгийн батлан хамгаалахын их сургууль, судалгааны байгууллагад суудал гаргаж, хамтарсан болон хос дипломын хөтөлбөрийн боловсруулалтыг эхлүүлэх.
+Тав: 2027 онд Монгол–Энэтхэгийн кибер аюулгүй байдлын анхны форумыг зохион байгуулж, олон улсын сургуулиудад хамтран оролцох.
+Эдгээр саналын зардал харьцангуй бага бөгөөд яг энэ байранд аль хэдийн бий болсон зүйл дээр шууд суурилна.
+— EN —
 To turn the roadmap into decisions, we put five proposals to the fourteenth Joint Working Group. One: record the expansion of the Centre project, Phase II, in the agenda and minutes. Two: confirm instructor deployment to 2029 and approve a 2027–2029 joint training plan with a train-the-trainer track. Three: agree a Phase II laboratory project – cyber range and SOC – with a technical assessment in 2027. Four: open seats for our faculty at Indian defence universities from 2027 and start designing joint and double-degree programmes. Five: hold the first Mongolia–India Cyber Security Forum in 2027 and take part together in the international exercises. Each builds directly on what already exists in this building.</a:t>
             </a:r>
             <a:endParaRPr lang="en-US" dirty="0"/>
@@ -2473,7 +2533,10 @@
           <a:p>
             <a:r>
               <a:rPr lang="en-US" dirty="0"/>
-              <a:t>МН: Баярлалаа. Асуулт, хэлэлцүүлэг; лабораторийн аялал.
+              <a:t>Слайд 26 · Баярлалаа — 0.5 мин
+Анхаарал тавьсанд баярлалаа. Энэ тэнхим Монгол–Энэтхэгийн батлан хамгаалах салбарын хамтын ажиллагааны хамгийн бодит үр дүн юм: Энэтхэгтэй хамт бүтээсэн, Монгол удирдан ажиллуулдаг, аюулгүй байдлын салбарт бүхэлд нь үйлчилдэг. Монголын кибер аюулгүй байдлын мэргэжилтнүүдийг бэлтгэхэд үнэтэй хувь нэмэр оруулсан Бүгд Найрамдах Энэтхэг Улсад, мэдлэг, ур чадвараа хуваалцсан сургалтын багийн бүх офицер, удирдлагад тэнхимийн хамт олны өмнөөс гүн талархал илэрхийлье.
+Та бүхний асуултад хариулахад бэлэн байна. Дараа нь лабораториудаар хамт явахыг урьж байна.
+— EN —
 Thank you. This Department is the most tangible product of India–Mongolia defence cooperation: built with India, run by Mongolia, and serving the whole security sector. We welcome your questions, and then invite you to see the laboratories.</a:t>
             </a:r>
             <a:endParaRPr lang="en-US" dirty="0"/>
@@ -2562,7 +2625,10 @@
           <a:p>
             <a:r>
               <a:rPr lang="en-US" dirty="0"/>
-              <a:t>МН: Хэсгийн хуудас.
+              <a:t>Слайд 3 · 01 — Хамтын ажиллагааны суурь
+[Хэсгийн хуудас. Нэг өгүүлбэр.]
+Эхний хэсэг: энэ төв ямар суурин дээр бий болсон бэ.
+— EN —
 Part one: the context in which this Centre was created.</a:t>
             </a:r>
             <a:endParaRPr lang="en-US" dirty="0"/>
@@ -2651,7 +2717,13 @@
           <a:p>
             <a:r>
               <a:rPr lang="en-US" dirty="0"/>
-              <a:t>МН: Түүхэн замнал: 1955 → 1994 гэрээ → 2001 БХ-ын хэлэлцээр → 2015 стратегийн түншлэл + Кибер төвийн санамж бичиг (05.17) → 2022 нээлт → 2025 Төрийн айлчлал.
+              <a:t>Слайд 4 · Долоон арван жилийн найрамдал, арван жилийн стратегийн түншлэл — 1.5 мин
+[Он дарааллын зүүнээс баруун тийш заана.]
+1955 оны 12 дугаар сарын 24-нд Энэтхэг улс Зөвлөлтийн блокоос гадуурх улсуудаас анх удаа Монгол Улстай дипломат харилцаа тогтоосон. 1994 оны Найрсаг харилцаа, хамтын ажиллагааны гэрээ, 2001 оны Батлан хамгаалах салбарын хамтын ажиллагааны хэлэлцээр хоёр улсын харилцааны эрх зүйн суурийг тавьсан. Өнөөдөр жил бүр хуралддаг зөвлөлдөх уулзалт яг тэр 2001 оны хэлэлцээрээс үүсэлтэй.
+2015 онд Ерөнхий сайд Нарендра Моди Монголд айлчилж, хоёр улс стратегийн түншлэл тогтоосон. Бидний хувьд хамгийн чухал нь: 2015 оны 5 дугаар сарын 17-нд хоёр улсын Засгийн газар Монгол Улсын Батлан хамгаалах яаманд Кибер аюулгүй байдлын сургалтын төв байгуулах тухай санамж бичигт гарын үсэг зурсан.
+Тэр төвийг 2022 оны 9 дүгээр сарын 6-нд, Энэтхэгийн Батлан хамгаалахын сайдын Монголд хийсэн анхны айлчлалын үеэр хоёр улсын Батлан хамгаалахын сайд нар хамтран нээсэн. Өнгөрсөн жилийн 10 дугаар сард Монгол Улсын Ерөнхийлөгч У.Хүрэлсүх Энэтхэгт Төрийн айлчлал хийж, дипломат харилцааны 70 жилийн ойг тэмдэглэсэн бөгөөд Энэтхэгийн тал Улаанбаатар дахь Элчин сайдын яамандаа Батлан хамгаалахын алба байгуулахаар шийдвэрлэсэн.
+[Доод хэсгийн өгүүлбэр рүү заана.] Товчхондоо, энэ төв 2015 онд тохирогдож, 2021–2022 онд баригдаж, 2023 оноос Энэтхэгийн сургалтын багуудтай ажиллаж байна. Батлан хамгаалах салбарын хамтын ажиллагааны хамгийн бодит, гар хүрч болох институц нь энэ юм.
+— EN —
 India was the first country outside the Soviet bloc to recognise Mongolia, in December 1955. The 1994 Treaty and the 2001 Agreement on Defence Cooperation gave the relationship its legal frame, and the Joint Working Group grew out of that agreement. The Strategic Partnership of 2015 opened the current chapter, and on 17 May 2015 the two governments signed the Memorandum to establish a Cyber Security Training Centre at our Ministry of Defence. That Centre was inaugurated on 6 September 2022 during the first-ever visit of an Indian Defence Minister. Last October, President Khurelsukh's state visit marked seventy years of relations and India decided to open a Defence Wing in Ulaanbaatar.</a:t>
             </a:r>
             <a:endParaRPr lang="en-US" dirty="0"/>
@@ -2740,7 +2812,13 @@
           <a:p>
             <a:r>
               <a:rPr lang="en-US" dirty="0"/>
-              <a:t>МН: Дөрвөн тулгуур: зөвлөлдөх уулзалт, хамтарсан сургууль, сургалт (ITEC), байгууллагууд. Кибер төв нь 4 дэх тулгуурын гол хэсэг.
+              <a:t>Слайд 5 · Батлан хамгаалах салбарын хамтын ажиллагааны дөрвөн тулгуур — 1 мин
+Өнөөдөр хоёр улсын батлан хамгаалах салбарын хамтын ажиллагаа дөрвөн тулгуур дээр тогтож байна.
+Нэгдүгээрт, бодлогын яриа хэлэлцээ. Хоёр яамны зөвлөлдөх уулзалт Нью-Дели, Улаанбаатар хотод ээлжлэн жил бүр хуралддаг: 11 дэх нь 2023 оны 2 сард Нью-Делид, 12 дахь нь 2024 оны 5 сард Улаанбаатарт, 13 дахь нь 2025 оны 2 сард Нью-Делид болсон. Өнөөдөр 14 дэх уулзалт.
+Хоёрдугаарт, хамтарсан сургууль. "Nomadic Elephant" сургууль 2004 оноос хойш 18 удаа зохион байгуулагдсан бөгөөд сүүлийн хоёр удаагийн сургуульд кибер аюулгүй байдлын сургалт хөтөлбөрт нь орсон. Энэтхэгийн баг "Хаан Квест" сургуульд жил бүр оролцдог.
+Гуравдугаарт, сургалт, чадавх бэхжүүлэх. ITEC хөтөлбөрөөр Монголд жил бүр 200 суудал олгодог бөгөөд өдийг хүртэл 3500 гаруй монгол мэргэжилтэн суралцсан. Манай офицерууд Энэтхэгийн цэргийн сургуулиудад суралцаж байна.
+Дөрөвдүгээрт, байгууллагууд: энэ төв, шинээр байгуулагдаж буй Батлан хамгаалахын алба, Энэтхэг–Монголын найрамдлын сургууль. Кибер аюулгүй байдлын тэнхим дөрөв дэх тулгуурын гол хэсэг бөгөөд нөгөө гурван тулгуурыг тэжээж байдаг.
+— EN —
 Our defence cooperation rests on four pillars. Policy dialogue: the Joint Working Group meets every year, alternating between New Delhi and Ulaanbaatar; this is its fourteenth meeting. Exercises: Nomadic Elephant has run since 2004 and in its last two editions included cyber security training, and India sends a contingent to Khaan Quest every year. Training: two hundred ITEC slots a year and more than three and a half thousand Mongolians trained. Institutions: this Centre, the new Defence Wing and the Friendship School. The Cyber Security Department sits at the centre of the fourth pillar and feeds the other three.</a:t>
             </a:r>
             <a:endParaRPr lang="en-US" dirty="0"/>
@@ -2829,7 +2907,10 @@
           <a:p>
             <a:r>
               <a:rPr lang="en-US" dirty="0"/>
-              <a:t>МН: Яагаад кибер: Монголын GCI үзүүлэлт (56.4, 103-р байр), долоо хоногт 90 мянган халдлага, 2021 оны хууль. Кибер аюулгүй байдлын цэргийн командлал – төвийн гол түнш.
+              <a:t>Слайд 6 · Яагаад кибер — 1 мин
+Яагаад яг кибер гэдэг асуултад тоогоор хариулъя. Олон улсын цахилгаан холбооны байгууллагын 2024 оны Кибер аюулгүй байдлын дэлхийн индексээр Монгол Улс 56.4 оноотой, 193 улсаас 103 дугаарт байна. 2020 оноос хойш 17 байраар ахисан ч Азийн дунджаас доогуур хэвээр. Үндэсний байгууллагуудын мэдээгээр Монголд долоо хоногт 90 мянга гаруй кибер халдлага илэрдэг. 2021 оны 12 дугаар сард батлагдсан Кибер аюулгүй байдлын тухай анхны хуулиар Зэвсэгт хүчин онц чухал дэд бүтцийг хамгаалахад дэмжлэг үзүүлэх үүрэгтэй болсон. Үүнийг хэрэгжүүлэхэд бэлтгэгдсэн хүн хэрэгтэй.
+Хоёр талын хэлэлцээрт кибер асуудал байнгын сэдэв болсон: 2022 онд нээсэн энэ төвийг Энэтхэгийн Батлан хамгаалахын яам кибер чиглэлийн олон улсын хамтын ажиллагааны анхны, цорын ганц төсөл гэж тодорхойлсон; "Nomadic Elephant" сургуулийн сүүлийн хоёр удаад кибер аюулгүй байдлын модуль орсон; Зэвсэгт хүчний Кибер аюулгүй байдлын цэргийн командлал манай төвийн анхны суралцагчдыг илгээсэн гол түнш юм. Хоёр улсын зэвсэгт хүчин ижил аюул заналтай тулгарч байна: хулгайлагч вирус, тагнуул, дэд бүтэц рүү чиглэсэн халдлага, мөн ижил чадварын хомсдол.
+— EN —
 Why cyber? Mongolia scores 56 in the ITU Global Cybersecurity Index, 103rd of 193. We have climbed seventeen places since 2020, but we remain below the Asian average. National authorities detect more than ninety thousand attacks a week. The 2021 Law on Cyber Security gives the Armed Forces a supporting role in protecting critical infrastructure, and that requires trained people. On the bilateral side, cyber is now a standing item: this Centre, the cyber modules of the last two Nomadic Elephant exercises, and the Cyber Security Military Command, which sent the first cohorts here and is our principal partner.</a:t>
             </a:r>
             <a:endParaRPr lang="en-US" dirty="0"/>
@@ -2918,7 +2999,10 @@
           <a:p>
             <a:r>
               <a:rPr lang="en-US" dirty="0"/>
-              <a:t>МН: Хэсгийн хуудас.
+              <a:t>Слайд 7 · 02 — Төвийг байгуулсан нь
+[Хэсгийн хуудас.]
+Хоёрдугаар хэсэг: төв хэрхэн бий болсон бэ.
+— EN —
 Part two: how the Centre came into being.</a:t>
             </a:r>
             <a:endParaRPr lang="en-US" dirty="0"/>
@@ -3007,7 +3091,12 @@
           <a:p>
             <a:r>
               <a:rPr lang="en-US" dirty="0"/>
-              <a:t>МН: 2015.05.17 санамж бичиг → 2021 барилга бэлтгэл, тээвэрлэлт → 2022.02 хүлээн авалт → 2022.03–07 угсралт (C-DAC, Sandeep Kumar) → 2022.09.06 нээлт → 2023.01 орон тоо → 2023.08 эхний баг → 2025.07 тэнхим.
+              <a:t>Слайд 8 · 2015 оны санамж бичгээс 2022 оны нээлт хүртэл — 1.5 мин
+Тохиролцооноос нээлт хүртэл долоон жил зарцуулагдсан. [Зүүн талын он дарааллаар дээрээс доош.]
+2015 оны 5 дугаар сарын 17-нд санамж бичигт гарын үсэг зурсан. 2021 онд ҮБХИС Цэргийн нэгдсэн сургуулийн байрны нэгдүгээр давхрыг засварлан бэлтгэж, Энэтхэгээс хоёр чингэлэг тоног төхөөрөмж ачигдан гарсан. 2022 оны 2 дугаар сард 93 нэр төрлийн тоног төхөөрөмж, программ, тавилга Улаанбаатарт ирсэн. 3–7 дугаар сард Си-Ди-Эй-Си буюу Энэтхэгийн Тооцоолол хөгжүүлэх төвийн инженер Сандип Кумар манай багтай хамтран лабораториудыг угсарч, ашиглалтад оруулсан; цахим сургалтын платформ 7 дугаар сарын 20-нд ажиллаж эхэлсэн.
+2022 оны 9 дүгээр сарын 6-нд Батлан хамгаалахын сайд Г.Сайханбаяр, Энэтхэгийн Батлан хамгаалахын сайд Ражнат Сингх нар төвийг нээсэн. [Баруун талын зураг руу заана.] Энэ бол тэр өдрийн зураг: тууз хайчилж буй мөч, Энэтхэгийн Батлан хамгаалахын сайдад зориулсан хүндэт харуул.
+2023 оны 1 дүгээр сард Батлан хамгаалах яам таван орон тоо баталж, төвийн дарга, гурван багшийг томилсон. 2023 оны 8 дугаар сард Энэтхэгийн анхны сургалтын баг ирсэн. 2025 оны 7 дугаар сард төв Цэргийн нэгдсэн сургуулийн бүрэн эрхт тэнхим болсон.
+— EN —
 The Centre took seven years from agreement to opening. The Memorandum was signed on 17 May 2015. In 2021 NDU renovated the first floor of the Military Institute building while two containers of equipment were dispatched from India. They were delivered in February 2022, and from March to July C-DAC's engineer Sandeep Kumar installed and commissioned the laboratories with our team; the e-learning platform went live on 20 July. On 6 September 2022 Defence Minister Saikhanbayar and Raksha Mantri Shri Rajnath Singh opened the Centre. In January 2023 the Ministry created five posts and appointed the head and three teachers; in August 2023 the first Indian training team arrived; and in July 2025 the Centre became a full department of the Military Institute.</a:t>
             </a:r>
             <a:endParaRPr lang="en-US" dirty="0"/>
@@ -3096,7 +3185,11 @@
           <a:p>
             <a:r>
               <a:rPr lang="en-US" dirty="0"/>
-              <a:t>МН: Энэтхэгийн хувь нэмэр: нийт 1.3 тэрбум төгрөгийн тоног төхөөрөмж (984 сая), программ (68.9 сая), e-learning систем (250.4 сая); 37 компьютер, 3 лаборатори, дата төв.
+              <a:t>Слайд 9 · Энэтхэгийн хувь нэмэр — 1.5 мин
+Энэтхэгийн тал зүгээр нэг анги танхим биш, бүрэн тоноглогдсон, иж бүрэн төв хүлээлгэн өгсөн. Нийлүүлэлтийн нийт үнэ 1.3 тэрбум төгрөг орчим: 984 сая төгрөгийн тоног төхөөрөмж, тавилга, материал — хоёр чингэлэгт 93 нэр төрөл; 68.9 сая төгрөгийн кибер аюулгүй байдлын программ хангамж; 250.4 сая төгрөгийн Си-Ди-Эй-Си-ийн цахим сургалтын систем, таван курсийн агуулга.
+[Баруун талын зургаан карт руу заана.] Эдгээр систем кибер аюулгүй байдлын бүх үйл явцыг хамардаг. Тооцоолол, сүлжээ: долоон Cisco сервер, NetApp өгөгдөл хадгалах систем, Cisco свитч, WatchGuard галт хана ба халдлага илрүүлэх систем, 37 ажлын станц. Тоон ул мөрийн шинжилгээ: Tableau хуулагч, бичилт хориглогч, Cellebrite, Oxygen, FTK програм, шинжилгээний ажлын станц. Хортой кодын шинжилгээ: IDA Pro, Hex-Rays декомпилятор, Sandboxie. Ослын хариу арга хэмжээ, аудит: Belkasoft, F-Response, Splunk, Nessus, Burp Suite, Acunetix, Netsparker. Цахим сургалт: Си-Ди-Эй-Си-ийн платформ дээрх таван курс — кибер аюулгүй байдлын суурь ойлголт, сүлжээний аюулгүй байдал, кибер гэмт хэргийн мөрдөн шалгалт, кибер болон гар утасны тоон ул мөрийн шинжилгээ. Мөн Си-Ди-Эй-Си-ийн өөрийн шинжилгээний багц хэрэгслүүд.
+Монголын тал Цэргийн нэгдсэн сургуулийн нэгдүгээр давхрын байр, түүний засвар, төвийн бие бүрэлдэхүүн, өдөр тутмын үйл ажиллагааг хариуцсан.
+— EN —
 India delivered a complete, equipped centre, not just a classroom. The supplies were worth about 1.3 billion tugrik: 984 million in equipment, furniture and materials, 93 items in two containers; 69 million in cyber security software; and 250 million for C-DAC's e-learning system with five courses. The systems cover the full cyber security workflow: servers, storage and a WatchGuard firewall; Tableau, Cellebrite and Oxygen forensic kits; IDA Pro and Hex-Rays for malware analysis; Belkasoft, Splunk, Nessus, Burp Suite and Acunetix for incident response and audit; and C-DAC's own cyber forensic tool kits. Mongolia provided the premises, their renovation, the staff and the operation.</a:t>
             </a:r>
             <a:endParaRPr lang="en-US" dirty="0"/>

</xml_diff>